<commit_message>
docs: Add email addresses for collaborators in README, slides, and abstract
</commit_message>
<xml_diff>
--- a/DOCUMENTS/Presentation.pptx
+++ b/DOCUMENTS/Presentation.pptx
@@ -3188,7 +3188,15 @@
             </a:r>
             <a:br/>
             <a:r>
-              <a:t>Akash V (710723106007) | Christina Joyce J (710723106019) | Gokul Midhun M N (710723106031)</a:t>
+              <a:t>Akash V (710723106007) - akashveeramuthu07@gmail.com</a:t>
+            </a:r>
+            <a:br/>
+            <a:r>
+              <a:t>Christina Joyce J (710723106019) - 23ec019@drngpit.ac.in</a:t>
+            </a:r>
+            <a:br/>
+            <a:r>
+              <a:t>Gokul Midhun M N (710723106031) - 23ec031@drngpit.ac.in</a:t>
             </a:r>
           </a:p>
           <a:p>

</xml_diff>